<commit_message>
Upgrade Lunch Is Packed to Riv Burger standard
</commit_message>
<xml_diff>
--- a/resources/presentations/Lunch-Is-Packed-Module-01-the-design-challenge.pptx
+++ b/resources/presentations/Lunch-Is-Packed-Module-01-the-design-challenge.pptx
@@ -2,20 +2,20 @@
 <file path=ppt/presentation.xml><?xml version="1.0" encoding="utf-8"?>
 <p:presentation xmlns:p="http://schemas.openxmlformats.org/presentationml/2006/main">
   <p:sldMasterIdLst>
-    <p:sldMasterId xmlns:r="http://schemas.openxmlformats.org/officeDocument/2006/relationships" id="2147483648" r:id="Rddd1afce14074834"/>
+    <p:sldMasterId xmlns:r="http://schemas.openxmlformats.org/officeDocument/2006/relationships" id="2147483648" r:id="Rc29ab91fefe54cc7"/>
   </p:sldMasterIdLst>
   <p:notesMasterIdLst>
-    <p:notesMasterId xmlns:r="http://schemas.openxmlformats.org/officeDocument/2006/relationships" r:id="Rd12074ab739c412e"/>
+    <p:notesMasterId xmlns:r="http://schemas.openxmlformats.org/officeDocument/2006/relationships" r:id="R458ade37f74c4c40"/>
   </p:notesMasterIdLst>
   <p:sldIdLst>
-    <p:sldId xmlns:r="http://schemas.openxmlformats.org/officeDocument/2006/relationships" id="256" r:id="R572ec407bddf4b9c"/>
-    <p:sldId xmlns:r="http://schemas.openxmlformats.org/officeDocument/2006/relationships" id="257" r:id="R96c3d7b99ba440cb"/>
-    <p:sldId xmlns:r="http://schemas.openxmlformats.org/officeDocument/2006/relationships" id="258" r:id="Re0e8644a1aa441b7"/>
-    <p:sldId xmlns:r="http://schemas.openxmlformats.org/officeDocument/2006/relationships" id="259" r:id="Rf10ee637ffd6425a"/>
-    <p:sldId xmlns:r="http://schemas.openxmlformats.org/officeDocument/2006/relationships" id="260" r:id="R4a713075af584357"/>
-    <p:sldId xmlns:r="http://schemas.openxmlformats.org/officeDocument/2006/relationships" id="261" r:id="Rdbed34296ff74580"/>
-    <p:sldId xmlns:r="http://schemas.openxmlformats.org/officeDocument/2006/relationships" id="262" r:id="Red5e407e3ffb4414"/>
-    <p:sldId xmlns:r="http://schemas.openxmlformats.org/officeDocument/2006/relationships" id="263" r:id="R69a018584c3b4752"/>
+    <p:sldId xmlns:r="http://schemas.openxmlformats.org/officeDocument/2006/relationships" id="256" r:id="Rf11b62b1e6b544c3"/>
+    <p:sldId xmlns:r="http://schemas.openxmlformats.org/officeDocument/2006/relationships" id="257" r:id="R931de362d5df4067"/>
+    <p:sldId xmlns:r="http://schemas.openxmlformats.org/officeDocument/2006/relationships" id="258" r:id="Rabc3192457a14a78"/>
+    <p:sldId xmlns:r="http://schemas.openxmlformats.org/officeDocument/2006/relationships" id="259" r:id="Rc7f134025d344392"/>
+    <p:sldId xmlns:r="http://schemas.openxmlformats.org/officeDocument/2006/relationships" id="260" r:id="Rcfe013c1ebcc4847"/>
+    <p:sldId xmlns:r="http://schemas.openxmlformats.org/officeDocument/2006/relationships" id="261" r:id="Rea7997957a544539"/>
+    <p:sldId xmlns:r="http://schemas.openxmlformats.org/officeDocument/2006/relationships" id="262" r:id="R8e77487941734ef3"/>
+    <p:sldId xmlns:r="http://schemas.openxmlformats.org/officeDocument/2006/relationships" id="263" r:id="R3a222825472442f6"/>
   </p:sldIdLst>
   <p:sldSz cx="12192000" cy="6858000"/>
   <p:notesSz cx="6858000" cy="9144000"/>
@@ -1127,7 +1127,7 @@
   </p:cSld>
   <p:clrMap bg1="lt1" tx1="dk1" bg2="lt2" tx2="dk2" accent1="accent1" accent2="accent2" accent3="accent3" accent4="accent4" accent5="accent5" accent6="accent6" hlink="hlink" folHlink="folHlink"/>
   <p:sldLayoutIdLst>
-    <p:sldLayoutId xmlns:r="http://schemas.openxmlformats.org/officeDocument/2006/relationships" id="2147483649" r:id="Raeed3e6f4ae94a7d"/>
+    <p:sldLayoutId xmlns:r="http://schemas.openxmlformats.org/officeDocument/2006/relationships" id="2147483649" r:id="R1c3345f47a364299"/>
   </p:sldLayoutIdLst>
   <p:txStyles>
     <p:titleStyle>
@@ -1678,7 +1678,7 @@
           <p:cNvPr id="7" name="title-plane">
             <a:extLst xmlns:a="http://schemas.openxmlformats.org/drawingml/2006/main">
               <a:ext uri="{FF2B5EF4-FFF2-40B4-BE49-F238E27FC236}">
-                <a16:creationId xmlns:a16="http://schemas.microsoft.com/office/drawing/2014/main" id="{CB11BBBF-2391-4B01-AF85-075383A0507B}"/>
+                <a16:creationId xmlns:a16="http://schemas.microsoft.com/office/drawing/2014/main" id="{8BC6545D-96FF-436C-90C9-06EF45A54B9A}"/>
               </a:ext>
             </a:extLst>
           </p:cNvPr>
@@ -1713,8 +1713,8 @@
           <p:nvPr/>
         </p:nvPicPr>
         <p:blipFill>
-          <a:blip xmlns:r="http://schemas.openxmlformats.org/officeDocument/2006/relationships" xmlns:a="http://schemas.openxmlformats.org/drawingml/2006/main" r:embed="R075a9dc91fa04eda"/>
-          <a:srcRect xmlns:a="http://schemas.openxmlformats.org/drawingml/2006/main" l="30134" t="0" r="30134" b="0"/>
+          <a:blip xmlns:r="http://schemas.openxmlformats.org/officeDocument/2006/relationships" xmlns:a="http://schemas.openxmlformats.org/drawingml/2006/main" r:embed="Rdf3f61a4a9b94fae"/>
+          <a:srcRect xmlns:a="http://schemas.openxmlformats.org/drawingml/2006/main" l="24074" t="0" r="24074" b="0"/>
           <a:stretch xmlns:a="http://schemas.openxmlformats.org/drawingml/2006/main">
             <a:fillRect l="0" t="0" r="0" b="0"/>
           </a:stretch>
@@ -1734,7 +1734,7 @@
           <p:cNvPr id="3" name="module-kicker">
             <a:extLst xmlns:a="http://schemas.openxmlformats.org/drawingml/2006/main">
               <a:ext uri="{FF2B5EF4-FFF2-40B4-BE49-F238E27FC236}">
-                <a16:creationId xmlns:a16="http://schemas.microsoft.com/office/drawing/2014/main" id="{EA20367C-156F-4403-AE03-6AB64DCBFF34}"/>
+                <a16:creationId xmlns:a16="http://schemas.microsoft.com/office/drawing/2014/main" id="{9B11BF61-F263-4B7A-8E97-9A5342DD7768}"/>
               </a:ext>
             </a:extLst>
           </p:cNvPr>
@@ -1784,7 +1784,7 @@
           <p:cNvPr id="4" name="deck-title">
             <a:extLst xmlns:a="http://schemas.openxmlformats.org/drawingml/2006/main">
               <a:ext uri="{FF2B5EF4-FFF2-40B4-BE49-F238E27FC236}">
-                <a16:creationId xmlns:a16="http://schemas.microsoft.com/office/drawing/2014/main" id="{2AB98F51-F7A8-4FE9-BD80-912220C41351}"/>
+                <a16:creationId xmlns:a16="http://schemas.microsoft.com/office/drawing/2014/main" id="{D64375AE-C628-42D8-85E9-AFEDFCF629DE}"/>
               </a:ext>
             </a:extLst>
           </p:cNvPr>
@@ -1834,7 +1834,7 @@
           <p:cNvPr id="5" name="deck-subtitle">
             <a:extLst xmlns:a="http://schemas.openxmlformats.org/drawingml/2006/main">
               <a:ext uri="{FF2B5EF4-FFF2-40B4-BE49-F238E27FC236}">
-                <a16:creationId xmlns:a16="http://schemas.microsoft.com/office/drawing/2014/main" id="{96923ECB-F8DE-41F2-91E8-ABEDDCC84780}"/>
+                <a16:creationId xmlns:a16="http://schemas.microsoft.com/office/drawing/2014/main" id="{DE47C9D5-39D2-463A-9B52-6FCAC215507F}"/>
               </a:ext>
             </a:extLst>
           </p:cNvPr>
@@ -1884,7 +1884,7 @@
           <p:cNvPr id="6" name="deck-footer">
             <a:extLst xmlns:a="http://schemas.openxmlformats.org/drawingml/2006/main">
               <a:ext uri="{FF2B5EF4-FFF2-40B4-BE49-F238E27FC236}">
-                <a16:creationId xmlns:a16="http://schemas.microsoft.com/office/drawing/2014/main" id="{F0EAF23D-02AE-410C-B677-875A7F451228}"/>
+                <a16:creationId xmlns:a16="http://schemas.microsoft.com/office/drawing/2014/main" id="{39744C0D-95B9-49D6-BD75-2ECEAF48082C}"/>
               </a:ext>
             </a:extLst>
           </p:cNvPr>
@@ -1932,7 +1932,7 @@
     </p:spTree>
     <p:extLst>
       <p:ext uri="{BB962C8B-B14F-4D97-AF65-F5344CB8AC3E}">
-        <p14:creationId xmlns:p14="http://schemas.microsoft.com/office/powerpoint/2010/main" val="1895160129"/>
+        <p14:creationId xmlns:p14="http://schemas.microsoft.com/office/powerpoint/2010/main" val="1455061179"/>
       </p:ext>
     </p:extLst>
   </p:cSld>
@@ -1963,7 +1963,7 @@
           <p:cNvPr id="15" name="top-rule">
             <a:extLst xmlns:a="http://schemas.openxmlformats.org/drawingml/2006/main">
               <a:ext uri="{FF2B5EF4-FFF2-40B4-BE49-F238E27FC236}">
-                <a16:creationId xmlns:a16="http://schemas.microsoft.com/office/drawing/2014/main" id="{C832720F-29C1-41F8-9A54-AA4782087A00}"/>
+                <a16:creationId xmlns:a16="http://schemas.microsoft.com/office/drawing/2014/main" id="{0E5384A5-F2CB-4B7C-8621-0494B1EC5205}"/>
               </a:ext>
             </a:extLst>
           </p:cNvPr>
@@ -1994,7 +1994,7 @@
           <p:cNvPr id="2" name="course-label">
             <a:extLst xmlns:a="http://schemas.openxmlformats.org/drawingml/2006/main">
               <a:ext uri="{FF2B5EF4-FFF2-40B4-BE49-F238E27FC236}">
-                <a16:creationId xmlns:a16="http://schemas.microsoft.com/office/drawing/2014/main" id="{27DB04EC-7365-4357-AFE7-CBE9B02614DC}"/>
+                <a16:creationId xmlns:a16="http://schemas.microsoft.com/office/drawing/2014/main" id="{24DD590C-D8AB-438B-995F-3C5DD766A74A}"/>
               </a:ext>
             </a:extLst>
           </p:cNvPr>
@@ -2044,7 +2044,7 @@
           <p:cNvPr id="3" name="module-label">
             <a:extLst xmlns:a="http://schemas.openxmlformats.org/drawingml/2006/main">
               <a:ext uri="{FF2B5EF4-FFF2-40B4-BE49-F238E27FC236}">
-                <a16:creationId xmlns:a16="http://schemas.microsoft.com/office/drawing/2014/main" id="{8B6DD801-42B4-4030-A961-8B2C00F50E60}"/>
+                <a16:creationId xmlns:a16="http://schemas.microsoft.com/office/drawing/2014/main" id="{AEBDB0DD-FDB9-4954-BC46-FD1314C02F07}"/>
               </a:ext>
             </a:extLst>
           </p:cNvPr>
@@ -2094,7 +2094,7 @@
           <p:cNvPr id="4" name="slide-title">
             <a:extLst xmlns:a="http://schemas.openxmlformats.org/drawingml/2006/main">
               <a:ext uri="{FF2B5EF4-FFF2-40B4-BE49-F238E27FC236}">
-                <a16:creationId xmlns:a16="http://schemas.microsoft.com/office/drawing/2014/main" id="{04F02BE0-1B08-488C-9CF4-551200D71816}"/>
+                <a16:creationId xmlns:a16="http://schemas.microsoft.com/office/drawing/2014/main" id="{45CDE0B3-919B-4341-BA63-AB5A1A9B6911}"/>
               </a:ext>
             </a:extLst>
           </p:cNvPr>
@@ -2144,7 +2144,7 @@
           <p:cNvPr id="5" name="slide-subtitle">
             <a:extLst xmlns:a="http://schemas.openxmlformats.org/drawingml/2006/main">
               <a:ext uri="{FF2B5EF4-FFF2-40B4-BE49-F238E27FC236}">
-                <a16:creationId xmlns:a16="http://schemas.microsoft.com/office/drawing/2014/main" id="{F1BAD068-28D2-45A0-A43D-B9D8639D000A}"/>
+                <a16:creationId xmlns:a16="http://schemas.microsoft.com/office/drawing/2014/main" id="{B6DD6ADD-15AC-4E99-AB51-67A4C2B65E9E}"/>
               </a:ext>
             </a:extLst>
           </p:cNvPr>
@@ -2194,7 +2194,7 @@
           <p:cNvPr id="6" name="bullet-1">
             <a:extLst xmlns:a="http://schemas.openxmlformats.org/drawingml/2006/main">
               <a:ext uri="{FF2B5EF4-FFF2-40B4-BE49-F238E27FC236}">
-                <a16:creationId xmlns:a16="http://schemas.microsoft.com/office/drawing/2014/main" id="{420BC4E1-1F7E-4FB0-B35C-68762425E583}"/>
+                <a16:creationId xmlns:a16="http://schemas.microsoft.com/office/drawing/2014/main" id="{B583A1A9-6B24-4EDA-8F7A-AD388ED13655}"/>
               </a:ext>
             </a:extLst>
           </p:cNvPr>
@@ -2225,7 +2225,7 @@
           <p:cNvPr id="7" name="bullet-number-1">
             <a:extLst xmlns:a="http://schemas.openxmlformats.org/drawingml/2006/main">
               <a:ext uri="{FF2B5EF4-FFF2-40B4-BE49-F238E27FC236}">
-                <a16:creationId xmlns:a16="http://schemas.microsoft.com/office/drawing/2014/main" id="{D748DABD-8373-4561-9769-F28FAF514C90}"/>
+                <a16:creationId xmlns:a16="http://schemas.microsoft.com/office/drawing/2014/main" id="{9504D077-C05C-4332-BB36-D387039DFAA5}"/>
               </a:ext>
             </a:extLst>
           </p:cNvPr>
@@ -2275,7 +2275,7 @@
           <p:cNvPr id="8" name="bullet-copy-1">
             <a:extLst xmlns:a="http://schemas.openxmlformats.org/drawingml/2006/main">
               <a:ext uri="{FF2B5EF4-FFF2-40B4-BE49-F238E27FC236}">
-                <a16:creationId xmlns:a16="http://schemas.microsoft.com/office/drawing/2014/main" id="{960532CB-92F7-4522-BB86-F1E8A339BDF1}"/>
+                <a16:creationId xmlns:a16="http://schemas.microsoft.com/office/drawing/2014/main" id="{46C8A19E-ABC4-4A8D-B939-BE178D38D4A2}"/>
               </a:ext>
             </a:extLst>
           </p:cNvPr>
@@ -2325,7 +2325,7 @@
           <p:cNvPr id="9" name="bullet-2">
             <a:extLst xmlns:a="http://schemas.openxmlformats.org/drawingml/2006/main">
               <a:ext uri="{FF2B5EF4-FFF2-40B4-BE49-F238E27FC236}">
-                <a16:creationId xmlns:a16="http://schemas.microsoft.com/office/drawing/2014/main" id="{237A95D1-3538-4953-BACE-CBFC0BDDA438}"/>
+                <a16:creationId xmlns:a16="http://schemas.microsoft.com/office/drawing/2014/main" id="{7005C759-C7C8-4E81-95F6-1AA15A35F9EC}"/>
               </a:ext>
             </a:extLst>
           </p:cNvPr>
@@ -2356,7 +2356,7 @@
           <p:cNvPr id="10" name="bullet-number-2">
             <a:extLst xmlns:a="http://schemas.openxmlformats.org/drawingml/2006/main">
               <a:ext uri="{FF2B5EF4-FFF2-40B4-BE49-F238E27FC236}">
-                <a16:creationId xmlns:a16="http://schemas.microsoft.com/office/drawing/2014/main" id="{77C8F581-A0F9-4A1C-9D9D-734E9DF5C18B}"/>
+                <a16:creationId xmlns:a16="http://schemas.microsoft.com/office/drawing/2014/main" id="{B57D745E-A3C6-4A1D-BEBA-2727A95052FB}"/>
               </a:ext>
             </a:extLst>
           </p:cNvPr>
@@ -2406,7 +2406,7 @@
           <p:cNvPr id="11" name="bullet-copy-2">
             <a:extLst xmlns:a="http://schemas.openxmlformats.org/drawingml/2006/main">
               <a:ext uri="{FF2B5EF4-FFF2-40B4-BE49-F238E27FC236}">
-                <a16:creationId xmlns:a16="http://schemas.microsoft.com/office/drawing/2014/main" id="{8CD77869-2C02-4780-8AB6-3A4F5C2FDABE}"/>
+                <a16:creationId xmlns:a16="http://schemas.microsoft.com/office/drawing/2014/main" id="{73825727-957E-43D9-913D-AC3E0EB0330C}"/>
               </a:ext>
             </a:extLst>
           </p:cNvPr>
@@ -2456,7 +2456,7 @@
           <p:cNvPr id="12" name="bullet-3">
             <a:extLst xmlns:a="http://schemas.openxmlformats.org/drawingml/2006/main">
               <a:ext uri="{FF2B5EF4-FFF2-40B4-BE49-F238E27FC236}">
-                <a16:creationId xmlns:a16="http://schemas.microsoft.com/office/drawing/2014/main" id="{34613DEB-7067-448A-B230-3AFDAF59BDB0}"/>
+                <a16:creationId xmlns:a16="http://schemas.microsoft.com/office/drawing/2014/main" id="{5BA83B46-1669-48E4-B7DA-E93857D5158C}"/>
               </a:ext>
             </a:extLst>
           </p:cNvPr>
@@ -2487,7 +2487,7 @@
           <p:cNvPr id="13" name="bullet-number-3">
             <a:extLst xmlns:a="http://schemas.openxmlformats.org/drawingml/2006/main">
               <a:ext uri="{FF2B5EF4-FFF2-40B4-BE49-F238E27FC236}">
-                <a16:creationId xmlns:a16="http://schemas.microsoft.com/office/drawing/2014/main" id="{CBF4A261-99F3-460C-A87A-2241566BA525}"/>
+                <a16:creationId xmlns:a16="http://schemas.microsoft.com/office/drawing/2014/main" id="{716BE794-F16B-458C-A3A8-736D8F432A9F}"/>
               </a:ext>
             </a:extLst>
           </p:cNvPr>
@@ -2537,7 +2537,7 @@
           <p:cNvPr id="14" name="bullet-copy-3">
             <a:extLst xmlns:a="http://schemas.openxmlformats.org/drawingml/2006/main">
               <a:ext uri="{FF2B5EF4-FFF2-40B4-BE49-F238E27FC236}">
-                <a16:creationId xmlns:a16="http://schemas.microsoft.com/office/drawing/2014/main" id="{EED70895-574F-4B00-A979-78156D051E4B}"/>
+                <a16:creationId xmlns:a16="http://schemas.microsoft.com/office/drawing/2014/main" id="{81564E69-8A48-45A7-ABC0-C689A398D5E2}"/>
               </a:ext>
             </a:extLst>
           </p:cNvPr>
@@ -2585,7 +2585,7 @@
     </p:spTree>
     <p:extLst>
       <p:ext uri="{BB962C8B-B14F-4D97-AF65-F5344CB8AC3E}">
-        <p14:creationId xmlns:p14="http://schemas.microsoft.com/office/powerpoint/2010/main" val="717871550"/>
+        <p14:creationId xmlns:p14="http://schemas.microsoft.com/office/powerpoint/2010/main" val="11832876"/>
       </p:ext>
     </p:extLst>
   </p:cSld>
@@ -2616,7 +2616,7 @@
           <p:cNvPr id="15" name="top-rule">
             <a:extLst xmlns:a="http://schemas.openxmlformats.org/drawingml/2006/main">
               <a:ext uri="{FF2B5EF4-FFF2-40B4-BE49-F238E27FC236}">
-                <a16:creationId xmlns:a16="http://schemas.microsoft.com/office/drawing/2014/main" id="{01FD4C06-CAAA-4FF3-8EAA-E72A2412C767}"/>
+                <a16:creationId xmlns:a16="http://schemas.microsoft.com/office/drawing/2014/main" id="{4388DBFC-50B4-4EF0-AE7D-5412F5E7517D}"/>
               </a:ext>
             </a:extLst>
           </p:cNvPr>
@@ -2647,7 +2647,7 @@
           <p:cNvPr id="2" name="course-label">
             <a:extLst xmlns:a="http://schemas.openxmlformats.org/drawingml/2006/main">
               <a:ext uri="{FF2B5EF4-FFF2-40B4-BE49-F238E27FC236}">
-                <a16:creationId xmlns:a16="http://schemas.microsoft.com/office/drawing/2014/main" id="{4A3722AE-D949-498F-AFF6-5EEAE871B14E}"/>
+                <a16:creationId xmlns:a16="http://schemas.microsoft.com/office/drawing/2014/main" id="{4B081F11-7069-4E31-88B6-6E6CADF754E4}"/>
               </a:ext>
             </a:extLst>
           </p:cNvPr>
@@ -2697,7 +2697,7 @@
           <p:cNvPr id="3" name="module-label">
             <a:extLst xmlns:a="http://schemas.openxmlformats.org/drawingml/2006/main">
               <a:ext uri="{FF2B5EF4-FFF2-40B4-BE49-F238E27FC236}">
-                <a16:creationId xmlns:a16="http://schemas.microsoft.com/office/drawing/2014/main" id="{59A7AFB6-9C90-4F26-89A5-2727FE7DADAA}"/>
+                <a16:creationId xmlns:a16="http://schemas.microsoft.com/office/drawing/2014/main" id="{8962665E-8EF4-4B7A-B72A-75A7812EE9FB}"/>
               </a:ext>
             </a:extLst>
           </p:cNvPr>
@@ -2747,7 +2747,7 @@
           <p:cNvPr id="4" name="slide-title">
             <a:extLst xmlns:a="http://schemas.openxmlformats.org/drawingml/2006/main">
               <a:ext uri="{FF2B5EF4-FFF2-40B4-BE49-F238E27FC236}">
-                <a16:creationId xmlns:a16="http://schemas.microsoft.com/office/drawing/2014/main" id="{B76431E1-33AD-49A1-9EA2-02857E6E284B}"/>
+                <a16:creationId xmlns:a16="http://schemas.microsoft.com/office/drawing/2014/main" id="{9B502C03-347C-421E-A5F3-96F66C154E6A}"/>
               </a:ext>
             </a:extLst>
           </p:cNvPr>
@@ -2797,7 +2797,7 @@
           <p:cNvPr id="5" name="slide-subtitle">
             <a:extLst xmlns:a="http://schemas.openxmlformats.org/drawingml/2006/main">
               <a:ext uri="{FF2B5EF4-FFF2-40B4-BE49-F238E27FC236}">
-                <a16:creationId xmlns:a16="http://schemas.microsoft.com/office/drawing/2014/main" id="{60D24824-D460-42F2-9502-C63B388C542F}"/>
+                <a16:creationId xmlns:a16="http://schemas.microsoft.com/office/drawing/2014/main" id="{BD6534F9-BF63-46CF-8891-8E70D8C97489}"/>
               </a:ext>
             </a:extLst>
           </p:cNvPr>
@@ -2847,7 +2847,7 @@
           <p:cNvPr id="6" name="bullet-1">
             <a:extLst xmlns:a="http://schemas.openxmlformats.org/drawingml/2006/main">
               <a:ext uri="{FF2B5EF4-FFF2-40B4-BE49-F238E27FC236}">
-                <a16:creationId xmlns:a16="http://schemas.microsoft.com/office/drawing/2014/main" id="{6005EB3E-C6C3-493D-A794-AD1EF2AF690E}"/>
+                <a16:creationId xmlns:a16="http://schemas.microsoft.com/office/drawing/2014/main" id="{F81878FA-16CF-432E-8E4F-A13ED5FF8942}"/>
               </a:ext>
             </a:extLst>
           </p:cNvPr>
@@ -2878,7 +2878,7 @@
           <p:cNvPr id="7" name="bullet-number-1">
             <a:extLst xmlns:a="http://schemas.openxmlformats.org/drawingml/2006/main">
               <a:ext uri="{FF2B5EF4-FFF2-40B4-BE49-F238E27FC236}">
-                <a16:creationId xmlns:a16="http://schemas.microsoft.com/office/drawing/2014/main" id="{167708B6-36DC-4B62-A7AF-3E86B9E84F34}"/>
+                <a16:creationId xmlns:a16="http://schemas.microsoft.com/office/drawing/2014/main" id="{79851C2A-FBE6-4656-9474-CCF18ECCF8BF}"/>
               </a:ext>
             </a:extLst>
           </p:cNvPr>
@@ -2928,7 +2928,7 @@
           <p:cNvPr id="8" name="bullet-copy-1">
             <a:extLst xmlns:a="http://schemas.openxmlformats.org/drawingml/2006/main">
               <a:ext uri="{FF2B5EF4-FFF2-40B4-BE49-F238E27FC236}">
-                <a16:creationId xmlns:a16="http://schemas.microsoft.com/office/drawing/2014/main" id="{312F68BB-6A73-48A0-9D34-A115732366CB}"/>
+                <a16:creationId xmlns:a16="http://schemas.microsoft.com/office/drawing/2014/main" id="{0F164382-AFA2-4FA6-BD48-0C7D20AB5F24}"/>
               </a:ext>
             </a:extLst>
           </p:cNvPr>
@@ -2978,7 +2978,7 @@
           <p:cNvPr id="9" name="bullet-2">
             <a:extLst xmlns:a="http://schemas.openxmlformats.org/drawingml/2006/main">
               <a:ext uri="{FF2B5EF4-FFF2-40B4-BE49-F238E27FC236}">
-                <a16:creationId xmlns:a16="http://schemas.microsoft.com/office/drawing/2014/main" id="{0817F61C-D17A-4283-B1C5-AD92BA272F04}"/>
+                <a16:creationId xmlns:a16="http://schemas.microsoft.com/office/drawing/2014/main" id="{9FCCC4DA-3DEB-4603-B052-2C154A2A9241}"/>
               </a:ext>
             </a:extLst>
           </p:cNvPr>
@@ -3009,7 +3009,7 @@
           <p:cNvPr id="10" name="bullet-number-2">
             <a:extLst xmlns:a="http://schemas.openxmlformats.org/drawingml/2006/main">
               <a:ext uri="{FF2B5EF4-FFF2-40B4-BE49-F238E27FC236}">
-                <a16:creationId xmlns:a16="http://schemas.microsoft.com/office/drawing/2014/main" id="{FD8A8ACF-8660-4900-8063-43E3160CDC96}"/>
+                <a16:creationId xmlns:a16="http://schemas.microsoft.com/office/drawing/2014/main" id="{61133C08-29BA-40FC-A711-0A453F65B5E3}"/>
               </a:ext>
             </a:extLst>
           </p:cNvPr>
@@ -3059,7 +3059,7 @@
           <p:cNvPr id="11" name="bullet-copy-2">
             <a:extLst xmlns:a="http://schemas.openxmlformats.org/drawingml/2006/main">
               <a:ext uri="{FF2B5EF4-FFF2-40B4-BE49-F238E27FC236}">
-                <a16:creationId xmlns:a16="http://schemas.microsoft.com/office/drawing/2014/main" id="{21EAAA24-D926-4B36-9BBF-3030FC4A16B0}"/>
+                <a16:creationId xmlns:a16="http://schemas.microsoft.com/office/drawing/2014/main" id="{033F06CF-923D-4208-A662-C215CE28F939}"/>
               </a:ext>
             </a:extLst>
           </p:cNvPr>
@@ -3099,7 +3099,7 @@
                   <a:srgbClr val="16343A"/>
                 </a:solidFill>
               </a:rPr>
-              <a:t>Packed lunches often rely on disposable wrapping and bags, while food also needs to be carried securely.</a:t>
+              <a:t>It identifies the product, intended user and important qualities without locking the designer into one answer.</a:t>
             </a:r>
           </a:p>
         </p:txBody>
@@ -3109,7 +3109,7 @@
           <p:cNvPr id="12" name="bullet-3">
             <a:extLst xmlns:a="http://schemas.openxmlformats.org/drawingml/2006/main">
               <a:ext uri="{FF2B5EF4-FFF2-40B4-BE49-F238E27FC236}">
-                <a16:creationId xmlns:a16="http://schemas.microsoft.com/office/drawing/2014/main" id="{1DCBFB1B-4250-4556-B002-FE5CA078F2B7}"/>
+                <a16:creationId xmlns:a16="http://schemas.microsoft.com/office/drawing/2014/main" id="{0309867E-C53B-443E-9731-1F91235AA7A1}"/>
               </a:ext>
             </a:extLst>
           </p:cNvPr>
@@ -3140,7 +3140,7 @@
           <p:cNvPr id="13" name="bullet-number-3">
             <a:extLst xmlns:a="http://schemas.openxmlformats.org/drawingml/2006/main">
               <a:ext uri="{FF2B5EF4-FFF2-40B4-BE49-F238E27FC236}">
-                <a16:creationId xmlns:a16="http://schemas.microsoft.com/office/drawing/2014/main" id="{EFC7C50B-58B0-43BA-BEF8-B4BC22401120}"/>
+                <a16:creationId xmlns:a16="http://schemas.microsoft.com/office/drawing/2014/main" id="{341079D4-99FD-4C04-9223-04C38F47133E}"/>
               </a:ext>
             </a:extLst>
           </p:cNvPr>
@@ -3190,7 +3190,7 @@
           <p:cNvPr id="14" name="bullet-copy-3">
             <a:extLst xmlns:a="http://schemas.openxmlformats.org/drawingml/2006/main">
               <a:ext uri="{FF2B5EF4-FFF2-40B4-BE49-F238E27FC236}">
-                <a16:creationId xmlns:a16="http://schemas.microsoft.com/office/drawing/2014/main" id="{AD13ABD3-BA6D-4CB3-96DF-FF556898743C}"/>
+                <a16:creationId xmlns:a16="http://schemas.microsoft.com/office/drawing/2014/main" id="{93CB0C64-8520-447A-A81B-F603DEB85D8B}"/>
               </a:ext>
             </a:extLst>
           </p:cNvPr>
@@ -3230,7 +3230,7 @@
                   <a:srgbClr val="16343A"/>
                 </a:solidFill>
               </a:rPr>
-              <a:t>The project asks you to develop a reusable textile solution for carrying a packed lunch.</a:t>
+              <a:t>Ask: What must this solution achieve, and what is still mine to decide?</a:t>
             </a:r>
           </a:p>
         </p:txBody>
@@ -3238,7 +3238,7 @@
     </p:spTree>
     <p:extLst>
       <p:ext uri="{BB962C8B-B14F-4D97-AF65-F5344CB8AC3E}">
-        <p14:creationId xmlns:p14="http://schemas.microsoft.com/office/powerpoint/2010/main" val="1889897300"/>
+        <p14:creationId xmlns:p14="http://schemas.microsoft.com/office/powerpoint/2010/main" val="597837803"/>
       </p:ext>
     </p:extLst>
   </p:cSld>
@@ -3269,7 +3269,7 @@
           <p:cNvPr id="12" name="top-rule">
             <a:extLst xmlns:a="http://schemas.openxmlformats.org/drawingml/2006/main">
               <a:ext uri="{FF2B5EF4-FFF2-40B4-BE49-F238E27FC236}">
-                <a16:creationId xmlns:a16="http://schemas.microsoft.com/office/drawing/2014/main" id="{5C93FBEC-4DA7-40D4-AF9F-C09183AC0258}"/>
+                <a16:creationId xmlns:a16="http://schemas.microsoft.com/office/drawing/2014/main" id="{D4A10092-8DF1-47C7-A56D-183E7F04E746}"/>
               </a:ext>
             </a:extLst>
           </p:cNvPr>
@@ -3300,7 +3300,7 @@
           <p:cNvPr id="2" name="course-label">
             <a:extLst xmlns:a="http://schemas.openxmlformats.org/drawingml/2006/main">
               <a:ext uri="{FF2B5EF4-FFF2-40B4-BE49-F238E27FC236}">
-                <a16:creationId xmlns:a16="http://schemas.microsoft.com/office/drawing/2014/main" id="{9892778E-EA19-449D-A3DB-40776C11DA56}"/>
+                <a16:creationId xmlns:a16="http://schemas.microsoft.com/office/drawing/2014/main" id="{66F7C72B-D703-4C8B-8E6C-85563A2633DC}"/>
               </a:ext>
             </a:extLst>
           </p:cNvPr>
@@ -3350,7 +3350,7 @@
           <p:cNvPr id="3" name="module-label">
             <a:extLst xmlns:a="http://schemas.openxmlformats.org/drawingml/2006/main">
               <a:ext uri="{FF2B5EF4-FFF2-40B4-BE49-F238E27FC236}">
-                <a16:creationId xmlns:a16="http://schemas.microsoft.com/office/drawing/2014/main" id="{AFED7348-004A-4F3B-9C33-6A6193A69283}"/>
+                <a16:creationId xmlns:a16="http://schemas.microsoft.com/office/drawing/2014/main" id="{FAF7A826-4B70-450A-AE5B-6042146BF07B}"/>
               </a:ext>
             </a:extLst>
           </p:cNvPr>
@@ -3400,7 +3400,7 @@
           <p:cNvPr id="4" name="slide-title">
             <a:extLst xmlns:a="http://schemas.openxmlformats.org/drawingml/2006/main">
               <a:ext uri="{FF2B5EF4-FFF2-40B4-BE49-F238E27FC236}">
-                <a16:creationId xmlns:a16="http://schemas.microsoft.com/office/drawing/2014/main" id="{6ACEF612-B60B-4584-84AA-BD0A3E73F3A8}"/>
+                <a16:creationId xmlns:a16="http://schemas.microsoft.com/office/drawing/2014/main" id="{4E7E48C0-484F-4096-A68A-7B61F3BF2FEB}"/>
               </a:ext>
             </a:extLst>
           </p:cNvPr>
@@ -3450,7 +3450,7 @@
           <p:cNvPr id="5" name="slide-subtitle">
             <a:extLst xmlns:a="http://schemas.openxmlformats.org/drawingml/2006/main">
               <a:ext uri="{FF2B5EF4-FFF2-40B4-BE49-F238E27FC236}">
-                <a16:creationId xmlns:a16="http://schemas.microsoft.com/office/drawing/2014/main" id="{0473AEDD-5F07-46D2-BB75-037C422FE6BC}"/>
+                <a16:creationId xmlns:a16="http://schemas.microsoft.com/office/drawing/2014/main" id="{131B3C2D-6ADC-462F-AFEF-2FAB98736561}"/>
               </a:ext>
             </a:extLst>
           </p:cNvPr>
@@ -3500,7 +3500,7 @@
           <p:cNvPr id="6" name="prompt-accent">
             <a:extLst xmlns:a="http://schemas.openxmlformats.org/drawingml/2006/main">
               <a:ext uri="{FF2B5EF4-FFF2-40B4-BE49-F238E27FC236}">
-                <a16:creationId xmlns:a16="http://schemas.microsoft.com/office/drawing/2014/main" id="{FFB9732F-8F73-4CD2-B44B-A3ED5FD407EF}"/>
+                <a16:creationId xmlns:a16="http://schemas.microsoft.com/office/drawing/2014/main" id="{E65A9232-A59A-4A1B-91B7-DDC25D5B1154}"/>
               </a:ext>
             </a:extLst>
           </p:cNvPr>
@@ -3531,7 +3531,7 @@
           <p:cNvPr id="7" name="plain-language">
             <a:extLst xmlns:a="http://schemas.openxmlformats.org/drawingml/2006/main">
               <a:ext uri="{FF2B5EF4-FFF2-40B4-BE49-F238E27FC236}">
-                <a16:creationId xmlns:a16="http://schemas.microsoft.com/office/drawing/2014/main" id="{9F95A2BE-B406-41E7-B717-180634298E8E}"/>
+                <a16:creationId xmlns:a16="http://schemas.microsoft.com/office/drawing/2014/main" id="{3E0D55D6-C407-43D2-89E7-DDB584E5DE22}"/>
               </a:ext>
             </a:extLst>
           </p:cNvPr>
@@ -3581,7 +3581,7 @@
           <p:cNvPr id="8" name="clarify">
             <a:extLst xmlns:a="http://schemas.openxmlformats.org/drawingml/2006/main">
               <a:ext uri="{FF2B5EF4-FFF2-40B4-BE49-F238E27FC236}">
-                <a16:creationId xmlns:a16="http://schemas.microsoft.com/office/drawing/2014/main" id="{54D7EB14-BCFF-4A85-B4BD-BE912F066E73}"/>
+                <a16:creationId xmlns:a16="http://schemas.microsoft.com/office/drawing/2014/main" id="{01DA18C1-835A-4DD6-ABF5-4F06E50DEB0F}"/>
               </a:ext>
             </a:extLst>
           </p:cNvPr>
@@ -3631,7 +3631,7 @@
           <p:cNvPr id="9" name="starter-label">
             <a:extLst xmlns:a="http://schemas.openxmlformats.org/drawingml/2006/main">
               <a:ext uri="{FF2B5EF4-FFF2-40B4-BE49-F238E27FC236}">
-                <a16:creationId xmlns:a16="http://schemas.microsoft.com/office/drawing/2014/main" id="{0A31CF3F-B652-4E06-A902-B207B4E82E02}"/>
+                <a16:creationId xmlns:a16="http://schemas.microsoft.com/office/drawing/2014/main" id="{C80C85A3-A272-40B2-B071-41B487D79BE0}"/>
               </a:ext>
             </a:extLst>
           </p:cNvPr>
@@ -3681,7 +3681,7 @@
           <p:cNvPr id="10" name="starter">
             <a:extLst xmlns:a="http://schemas.openxmlformats.org/drawingml/2006/main">
               <a:ext uri="{FF2B5EF4-FFF2-40B4-BE49-F238E27FC236}">
-                <a16:creationId xmlns:a16="http://schemas.microsoft.com/office/drawing/2014/main" id="{D9441F72-3C64-4B84-ACD9-8525F896064E}"/>
+                <a16:creationId xmlns:a16="http://schemas.microsoft.com/office/drawing/2014/main" id="{A132CE69-C934-4A33-A223-2378BC9F1B40}"/>
               </a:ext>
             </a:extLst>
           </p:cNvPr>
@@ -3731,7 +3731,7 @@
           <p:cNvPr id="11" name="action">
             <a:extLst xmlns:a="http://schemas.openxmlformats.org/drawingml/2006/main">
               <a:ext uri="{FF2B5EF4-FFF2-40B4-BE49-F238E27FC236}">
-                <a16:creationId xmlns:a16="http://schemas.microsoft.com/office/drawing/2014/main" id="{43E67E48-698C-4840-BAAD-046F3D7DD13C}"/>
+                <a16:creationId xmlns:a16="http://schemas.microsoft.com/office/drawing/2014/main" id="{0108B306-74D1-4522-9E55-F2F3D4738FD6}"/>
               </a:ext>
             </a:extLst>
           </p:cNvPr>
@@ -3779,7 +3779,7 @@
     </p:spTree>
     <p:extLst>
       <p:ext uri="{BB962C8B-B14F-4D97-AF65-F5344CB8AC3E}">
-        <p14:creationId xmlns:p14="http://schemas.microsoft.com/office/powerpoint/2010/main" val="228412847"/>
+        <p14:creationId xmlns:p14="http://schemas.microsoft.com/office/powerpoint/2010/main" val="76837966"/>
       </p:ext>
     </p:extLst>
   </p:cSld>
@@ -3810,7 +3810,7 @@
           <p:cNvPr id="15" name="top-rule">
             <a:extLst xmlns:a="http://schemas.openxmlformats.org/drawingml/2006/main">
               <a:ext uri="{FF2B5EF4-FFF2-40B4-BE49-F238E27FC236}">
-                <a16:creationId xmlns:a16="http://schemas.microsoft.com/office/drawing/2014/main" id="{699F8722-268C-41DE-B2A3-A6E5EC039AD2}"/>
+                <a16:creationId xmlns:a16="http://schemas.microsoft.com/office/drawing/2014/main" id="{05FBCB88-2786-4562-B1A9-574B1DC482E0}"/>
               </a:ext>
             </a:extLst>
           </p:cNvPr>
@@ -3841,7 +3841,7 @@
           <p:cNvPr id="2" name="course-label">
             <a:extLst xmlns:a="http://schemas.openxmlformats.org/drawingml/2006/main">
               <a:ext uri="{FF2B5EF4-FFF2-40B4-BE49-F238E27FC236}">
-                <a16:creationId xmlns:a16="http://schemas.microsoft.com/office/drawing/2014/main" id="{9411050C-12B4-4782-81E2-B8649FCBBC58}"/>
+                <a16:creationId xmlns:a16="http://schemas.microsoft.com/office/drawing/2014/main" id="{9A4660AC-2A56-4803-9261-61FE4CA9295A}"/>
               </a:ext>
             </a:extLst>
           </p:cNvPr>
@@ -3891,7 +3891,7 @@
           <p:cNvPr id="3" name="module-label">
             <a:extLst xmlns:a="http://schemas.openxmlformats.org/drawingml/2006/main">
               <a:ext uri="{FF2B5EF4-FFF2-40B4-BE49-F238E27FC236}">
-                <a16:creationId xmlns:a16="http://schemas.microsoft.com/office/drawing/2014/main" id="{0AF2D7FE-CEF0-4541-B5F6-852B8F04EC4F}"/>
+                <a16:creationId xmlns:a16="http://schemas.microsoft.com/office/drawing/2014/main" id="{C6CE030C-0408-4655-824E-C9AEA1013CBD}"/>
               </a:ext>
             </a:extLst>
           </p:cNvPr>
@@ -3941,7 +3941,7 @@
           <p:cNvPr id="4" name="slide-title">
             <a:extLst xmlns:a="http://schemas.openxmlformats.org/drawingml/2006/main">
               <a:ext uri="{FF2B5EF4-FFF2-40B4-BE49-F238E27FC236}">
-                <a16:creationId xmlns:a16="http://schemas.microsoft.com/office/drawing/2014/main" id="{2C8A7097-325A-4DA0-B673-3F7207CE6E8A}"/>
+                <a16:creationId xmlns:a16="http://schemas.microsoft.com/office/drawing/2014/main" id="{F365F731-D554-412B-9155-27F6D532A535}"/>
               </a:ext>
             </a:extLst>
           </p:cNvPr>
@@ -3991,7 +3991,7 @@
           <p:cNvPr id="5" name="slide-subtitle">
             <a:extLst xmlns:a="http://schemas.openxmlformats.org/drawingml/2006/main">
               <a:ext uri="{FF2B5EF4-FFF2-40B4-BE49-F238E27FC236}">
-                <a16:creationId xmlns:a16="http://schemas.microsoft.com/office/drawing/2014/main" id="{8CF53764-23FA-46C9-81F0-A54E7E1037E7}"/>
+                <a16:creationId xmlns:a16="http://schemas.microsoft.com/office/drawing/2014/main" id="{CA78E181-95ED-4957-90FE-38BA0F82479C}"/>
               </a:ext>
             </a:extLst>
           </p:cNvPr>
@@ -4041,7 +4041,7 @@
           <p:cNvPr id="6" name="bullet-1">
             <a:extLst xmlns:a="http://schemas.openxmlformats.org/drawingml/2006/main">
               <a:ext uri="{FF2B5EF4-FFF2-40B4-BE49-F238E27FC236}">
-                <a16:creationId xmlns:a16="http://schemas.microsoft.com/office/drawing/2014/main" id="{4C6B856C-3F14-47B3-907C-75AAD5371742}"/>
+                <a16:creationId xmlns:a16="http://schemas.microsoft.com/office/drawing/2014/main" id="{733344AB-E299-4171-9EFD-D5EC4698399C}"/>
               </a:ext>
             </a:extLst>
           </p:cNvPr>
@@ -4072,7 +4072,7 @@
           <p:cNvPr id="7" name="bullet-number-1">
             <a:extLst xmlns:a="http://schemas.openxmlformats.org/drawingml/2006/main">
               <a:ext uri="{FF2B5EF4-FFF2-40B4-BE49-F238E27FC236}">
-                <a16:creationId xmlns:a16="http://schemas.microsoft.com/office/drawing/2014/main" id="{7515B659-138F-48E6-B51D-3FF0C3E856B4}"/>
+                <a16:creationId xmlns:a16="http://schemas.microsoft.com/office/drawing/2014/main" id="{639FA651-C59C-43AC-ADD2-4B6AE55CDF4B}"/>
               </a:ext>
             </a:extLst>
           </p:cNvPr>
@@ -4122,7 +4122,7 @@
           <p:cNvPr id="8" name="bullet-copy-1">
             <a:extLst xmlns:a="http://schemas.openxmlformats.org/drawingml/2006/main">
               <a:ext uri="{FF2B5EF4-FFF2-40B4-BE49-F238E27FC236}">
-                <a16:creationId xmlns:a16="http://schemas.microsoft.com/office/drawing/2014/main" id="{4CE5724F-2BE9-4DA9-A72A-F9203B7B2329}"/>
+                <a16:creationId xmlns:a16="http://schemas.microsoft.com/office/drawing/2014/main" id="{2C4BEE11-CC1C-4FAB-B952-3779BB8BEA21}"/>
               </a:ext>
             </a:extLst>
           </p:cNvPr>
@@ -4172,7 +4172,7 @@
           <p:cNvPr id="9" name="bullet-2">
             <a:extLst xmlns:a="http://schemas.openxmlformats.org/drawingml/2006/main">
               <a:ext uri="{FF2B5EF4-FFF2-40B4-BE49-F238E27FC236}">
-                <a16:creationId xmlns:a16="http://schemas.microsoft.com/office/drawing/2014/main" id="{B77125FE-663A-44E7-AFE1-707003B5C305}"/>
+                <a16:creationId xmlns:a16="http://schemas.microsoft.com/office/drawing/2014/main" id="{4D3BD16C-0F72-4FF8-8E77-6806D2026EB1}"/>
               </a:ext>
             </a:extLst>
           </p:cNvPr>
@@ -4203,7 +4203,7 @@
           <p:cNvPr id="10" name="bullet-number-2">
             <a:extLst xmlns:a="http://schemas.openxmlformats.org/drawingml/2006/main">
               <a:ext uri="{FF2B5EF4-FFF2-40B4-BE49-F238E27FC236}">
-                <a16:creationId xmlns:a16="http://schemas.microsoft.com/office/drawing/2014/main" id="{3FE6FEB0-D85B-4302-AFB9-97BFE4D402AA}"/>
+                <a16:creationId xmlns:a16="http://schemas.microsoft.com/office/drawing/2014/main" id="{31AF120F-BF83-4063-A435-B7B03976718C}"/>
               </a:ext>
             </a:extLst>
           </p:cNvPr>
@@ -4253,7 +4253,7 @@
           <p:cNvPr id="11" name="bullet-copy-2">
             <a:extLst xmlns:a="http://schemas.openxmlformats.org/drawingml/2006/main">
               <a:ext uri="{FF2B5EF4-FFF2-40B4-BE49-F238E27FC236}">
-                <a16:creationId xmlns:a16="http://schemas.microsoft.com/office/drawing/2014/main" id="{B20990CB-3C14-4BD0-8B34-AC16E9D01158}"/>
+                <a16:creationId xmlns:a16="http://schemas.microsoft.com/office/drawing/2014/main" id="{D16FB895-BF70-4CC5-BE4A-30D7DBB90179}"/>
               </a:ext>
             </a:extLst>
           </p:cNvPr>
@@ -4293,7 +4293,7 @@
                   <a:srgbClr val="16343A"/>
                 </a:solidFill>
               </a:rPr>
-              <a:t>A student may need a lunch bag that is easy to carry, simple to open, suitable for their lunch and recognisable among other bags.</a:t>
+              <a:t>Before lunch, the bag must be packed and carried.</a:t>
             </a:r>
           </a:p>
         </p:txBody>
@@ -4303,7 +4303,7 @@
           <p:cNvPr id="12" name="bullet-3">
             <a:extLst xmlns:a="http://schemas.openxmlformats.org/drawingml/2006/main">
               <a:ext uri="{FF2B5EF4-FFF2-40B4-BE49-F238E27FC236}">
-                <a16:creationId xmlns:a16="http://schemas.microsoft.com/office/drawing/2014/main" id="{7EEEE697-9DD9-45B9-BC93-074A965FCB15}"/>
+                <a16:creationId xmlns:a16="http://schemas.microsoft.com/office/drawing/2014/main" id="{BB319A1A-A175-403A-BD50-4B10A3884AA1}"/>
               </a:ext>
             </a:extLst>
           </p:cNvPr>
@@ -4334,7 +4334,7 @@
           <p:cNvPr id="13" name="bullet-number-3">
             <a:extLst xmlns:a="http://schemas.openxmlformats.org/drawingml/2006/main">
               <a:ext uri="{FF2B5EF4-FFF2-40B4-BE49-F238E27FC236}">
-                <a16:creationId xmlns:a16="http://schemas.microsoft.com/office/drawing/2014/main" id="{61BCD2E5-20B7-456F-821C-98879A7E29DA}"/>
+                <a16:creationId xmlns:a16="http://schemas.microsoft.com/office/drawing/2014/main" id="{40891DC0-8F73-47E5-82CA-736E9FBA3E23}"/>
               </a:ext>
             </a:extLst>
           </p:cNvPr>
@@ -4384,7 +4384,7 @@
           <p:cNvPr id="14" name="bullet-copy-3">
             <a:extLst xmlns:a="http://schemas.openxmlformats.org/drawingml/2006/main">
               <a:ext uri="{FF2B5EF4-FFF2-40B4-BE49-F238E27FC236}">
-                <a16:creationId xmlns:a16="http://schemas.microsoft.com/office/drawing/2014/main" id="{7D96A0B7-8F97-4FBF-8A2A-4F27D6E835DB}"/>
+                <a16:creationId xmlns:a16="http://schemas.microsoft.com/office/drawing/2014/main" id="{076B8F0B-04B5-4533-AF0A-BB7F4F8A9A05}"/>
               </a:ext>
             </a:extLst>
           </p:cNvPr>
@@ -4424,7 +4424,7 @@
                   <a:srgbClr val="16343A"/>
                 </a:solidFill>
               </a:rPr>
-              <a:t>The maker needs a design that can be produced safely with available materials, equipment, skills and lesson time.</a:t>
+              <a:t>This prevents a design from becoming a collection of untested extras.</a:t>
             </a:r>
           </a:p>
         </p:txBody>
@@ -4432,7 +4432,7 @@
     </p:spTree>
     <p:extLst>
       <p:ext uri="{BB962C8B-B14F-4D97-AF65-F5344CB8AC3E}">
-        <p14:creationId xmlns:p14="http://schemas.microsoft.com/office/powerpoint/2010/main" val="1166343280"/>
+        <p14:creationId xmlns:p14="http://schemas.microsoft.com/office/powerpoint/2010/main" val="170653530"/>
       </p:ext>
     </p:extLst>
   </p:cSld>
@@ -4463,7 +4463,7 @@
           <p:cNvPr id="12" name="top-rule">
             <a:extLst xmlns:a="http://schemas.openxmlformats.org/drawingml/2006/main">
               <a:ext uri="{FF2B5EF4-FFF2-40B4-BE49-F238E27FC236}">
-                <a16:creationId xmlns:a16="http://schemas.microsoft.com/office/drawing/2014/main" id="{B9B869A2-D1C2-498A-9A2A-5BD54C88C7DF}"/>
+                <a16:creationId xmlns:a16="http://schemas.microsoft.com/office/drawing/2014/main" id="{BB09B168-A674-4EBD-887E-F135FF36A53A}"/>
               </a:ext>
             </a:extLst>
           </p:cNvPr>
@@ -4494,7 +4494,7 @@
           <p:cNvPr id="2" name="course-label">
             <a:extLst xmlns:a="http://schemas.openxmlformats.org/drawingml/2006/main">
               <a:ext uri="{FF2B5EF4-FFF2-40B4-BE49-F238E27FC236}">
-                <a16:creationId xmlns:a16="http://schemas.microsoft.com/office/drawing/2014/main" id="{07E5934C-015B-4FEF-B267-5248FB03A15A}"/>
+                <a16:creationId xmlns:a16="http://schemas.microsoft.com/office/drawing/2014/main" id="{5F8BE095-522A-4AF7-B0FD-7D7EECC6925E}"/>
               </a:ext>
             </a:extLst>
           </p:cNvPr>
@@ -4544,7 +4544,7 @@
           <p:cNvPr id="3" name="module-label">
             <a:extLst xmlns:a="http://schemas.openxmlformats.org/drawingml/2006/main">
               <a:ext uri="{FF2B5EF4-FFF2-40B4-BE49-F238E27FC236}">
-                <a16:creationId xmlns:a16="http://schemas.microsoft.com/office/drawing/2014/main" id="{FA7B3CD3-98C8-4093-998B-05A247878958}"/>
+                <a16:creationId xmlns:a16="http://schemas.microsoft.com/office/drawing/2014/main" id="{49AFDF8D-01E4-44AE-9A87-D22802C0A35B}"/>
               </a:ext>
             </a:extLst>
           </p:cNvPr>
@@ -4594,7 +4594,7 @@
           <p:cNvPr id="4" name="slide-title">
             <a:extLst xmlns:a="http://schemas.openxmlformats.org/drawingml/2006/main">
               <a:ext uri="{FF2B5EF4-FFF2-40B4-BE49-F238E27FC236}">
-                <a16:creationId xmlns:a16="http://schemas.microsoft.com/office/drawing/2014/main" id="{98A960C9-BFC5-41BC-8392-1ABC1109688C}"/>
+                <a16:creationId xmlns:a16="http://schemas.microsoft.com/office/drawing/2014/main" id="{BF083FFC-20EA-4E8D-91BD-C17E26355889}"/>
               </a:ext>
             </a:extLst>
           </p:cNvPr>
@@ -4644,7 +4644,7 @@
           <p:cNvPr id="5" name="slide-subtitle">
             <a:extLst xmlns:a="http://schemas.openxmlformats.org/drawingml/2006/main">
               <a:ext uri="{FF2B5EF4-FFF2-40B4-BE49-F238E27FC236}">
-                <a16:creationId xmlns:a16="http://schemas.microsoft.com/office/drawing/2014/main" id="{A29B894C-9657-4DEC-9866-5A2F3E32C8EF}"/>
+                <a16:creationId xmlns:a16="http://schemas.microsoft.com/office/drawing/2014/main" id="{A3C4B3CA-A35C-42AF-A802-77E2511A1A24}"/>
               </a:ext>
             </a:extLst>
           </p:cNvPr>
@@ -4694,7 +4694,7 @@
           <p:cNvPr id="6" name="prompt-accent">
             <a:extLst xmlns:a="http://schemas.openxmlformats.org/drawingml/2006/main">
               <a:ext uri="{FF2B5EF4-FFF2-40B4-BE49-F238E27FC236}">
-                <a16:creationId xmlns:a16="http://schemas.microsoft.com/office/drawing/2014/main" id="{B4CD7A6A-335D-421B-B986-B58B5A4376DB}"/>
+                <a16:creationId xmlns:a16="http://schemas.microsoft.com/office/drawing/2014/main" id="{6EBC205F-E3B1-4B60-8AD2-4E050A47CAC5}"/>
               </a:ext>
             </a:extLst>
           </p:cNvPr>
@@ -4725,7 +4725,7 @@
           <p:cNvPr id="7" name="plain-language">
             <a:extLst xmlns:a="http://schemas.openxmlformats.org/drawingml/2006/main">
               <a:ext uri="{FF2B5EF4-FFF2-40B4-BE49-F238E27FC236}">
-                <a16:creationId xmlns:a16="http://schemas.microsoft.com/office/drawing/2014/main" id="{98FB49A7-A79A-49CD-9EE2-65BC12D193B2}"/>
+                <a16:creationId xmlns:a16="http://schemas.microsoft.com/office/drawing/2014/main" id="{BC2D100D-E948-4878-BC2C-D2A981F84E1F}"/>
               </a:ext>
             </a:extLst>
           </p:cNvPr>
@@ -4775,7 +4775,7 @@
           <p:cNvPr id="8" name="clarify">
             <a:extLst xmlns:a="http://schemas.openxmlformats.org/drawingml/2006/main">
               <a:ext uri="{FF2B5EF4-FFF2-40B4-BE49-F238E27FC236}">
-                <a16:creationId xmlns:a16="http://schemas.microsoft.com/office/drawing/2014/main" id="{57A3626E-D44E-42D6-B67E-1D6FC7261ADF}"/>
+                <a16:creationId xmlns:a16="http://schemas.microsoft.com/office/drawing/2014/main" id="{3622B9E7-2A5D-402A-9138-E3DACFF3A22D}"/>
               </a:ext>
             </a:extLst>
           </p:cNvPr>
@@ -4825,7 +4825,7 @@
           <p:cNvPr id="9" name="starter-label">
             <a:extLst xmlns:a="http://schemas.openxmlformats.org/drawingml/2006/main">
               <a:ext uri="{FF2B5EF4-FFF2-40B4-BE49-F238E27FC236}">
-                <a16:creationId xmlns:a16="http://schemas.microsoft.com/office/drawing/2014/main" id="{522A1B07-47C4-4596-ADAF-CD3916FB017D}"/>
+                <a16:creationId xmlns:a16="http://schemas.microsoft.com/office/drawing/2014/main" id="{CF28BD5B-7EDC-4BDD-9512-9F23089DF880}"/>
               </a:ext>
             </a:extLst>
           </p:cNvPr>
@@ -4875,7 +4875,7 @@
           <p:cNvPr id="10" name="starter">
             <a:extLst xmlns:a="http://schemas.openxmlformats.org/drawingml/2006/main">
               <a:ext uri="{FF2B5EF4-FFF2-40B4-BE49-F238E27FC236}">
-                <a16:creationId xmlns:a16="http://schemas.microsoft.com/office/drawing/2014/main" id="{C1C41A4C-F1E8-4043-95FC-80C3A2177A11}"/>
+                <a16:creationId xmlns:a16="http://schemas.microsoft.com/office/drawing/2014/main" id="{942B1464-D390-4C5D-93C9-7EF9D2EEE3D4}"/>
               </a:ext>
             </a:extLst>
           </p:cNvPr>
@@ -4925,7 +4925,7 @@
           <p:cNvPr id="11" name="action">
             <a:extLst xmlns:a="http://schemas.openxmlformats.org/drawingml/2006/main">
               <a:ext uri="{FF2B5EF4-FFF2-40B4-BE49-F238E27FC236}">
-                <a16:creationId xmlns:a16="http://schemas.microsoft.com/office/drawing/2014/main" id="{E6C4492C-2DA8-422B-8736-22D3B4AF43BA}"/>
+                <a16:creationId xmlns:a16="http://schemas.microsoft.com/office/drawing/2014/main" id="{0B702656-784F-4EF8-9B07-0A9EC245607F}"/>
               </a:ext>
             </a:extLst>
           </p:cNvPr>
@@ -4973,7 +4973,7 @@
     </p:spTree>
     <p:extLst>
       <p:ext uri="{BB962C8B-B14F-4D97-AF65-F5344CB8AC3E}">
-        <p14:creationId xmlns:p14="http://schemas.microsoft.com/office/powerpoint/2010/main" val="889588985"/>
+        <p14:creationId xmlns:p14="http://schemas.microsoft.com/office/powerpoint/2010/main" val="1717031889"/>
       </p:ext>
     </p:extLst>
   </p:cSld>
@@ -5004,7 +5004,7 @@
           <p:cNvPr id="15" name="top-rule">
             <a:extLst xmlns:a="http://schemas.openxmlformats.org/drawingml/2006/main">
               <a:ext uri="{FF2B5EF4-FFF2-40B4-BE49-F238E27FC236}">
-                <a16:creationId xmlns:a16="http://schemas.microsoft.com/office/drawing/2014/main" id="{AFD56F59-DF6D-462A-8E24-27598B7119D5}"/>
+                <a16:creationId xmlns:a16="http://schemas.microsoft.com/office/drawing/2014/main" id="{50C850F2-1907-4A0B-99A6-16FDB0D62B76}"/>
               </a:ext>
             </a:extLst>
           </p:cNvPr>
@@ -5035,7 +5035,7 @@
           <p:cNvPr id="2" name="course-label">
             <a:extLst xmlns:a="http://schemas.openxmlformats.org/drawingml/2006/main">
               <a:ext uri="{FF2B5EF4-FFF2-40B4-BE49-F238E27FC236}">
-                <a16:creationId xmlns:a16="http://schemas.microsoft.com/office/drawing/2014/main" id="{DC35C420-4AF7-4EC8-8C67-6AB2C0DD4282}"/>
+                <a16:creationId xmlns:a16="http://schemas.microsoft.com/office/drawing/2014/main" id="{6945B79B-B051-4F57-9EE2-3CC7D089711B}"/>
               </a:ext>
             </a:extLst>
           </p:cNvPr>
@@ -5085,7 +5085,7 @@
           <p:cNvPr id="3" name="module-label">
             <a:extLst xmlns:a="http://schemas.openxmlformats.org/drawingml/2006/main">
               <a:ext uri="{FF2B5EF4-FFF2-40B4-BE49-F238E27FC236}">
-                <a16:creationId xmlns:a16="http://schemas.microsoft.com/office/drawing/2014/main" id="{31FCDBA7-1BB8-4C65-A2FB-BBE070B31594}"/>
+                <a16:creationId xmlns:a16="http://schemas.microsoft.com/office/drawing/2014/main" id="{1516F30B-7EFC-4C22-B8DD-615A9B6B7DB1}"/>
               </a:ext>
             </a:extLst>
           </p:cNvPr>
@@ -5135,7 +5135,7 @@
           <p:cNvPr id="4" name="slide-title">
             <a:extLst xmlns:a="http://schemas.openxmlformats.org/drawingml/2006/main">
               <a:ext uri="{FF2B5EF4-FFF2-40B4-BE49-F238E27FC236}">
-                <a16:creationId xmlns:a16="http://schemas.microsoft.com/office/drawing/2014/main" id="{11727C19-C247-4D6D-82A1-5266C5D7DB89}"/>
+                <a16:creationId xmlns:a16="http://schemas.microsoft.com/office/drawing/2014/main" id="{0376A61B-4CA7-43E9-B539-3CC9914C4E80}"/>
               </a:ext>
             </a:extLst>
           </p:cNvPr>
@@ -5185,7 +5185,7 @@
           <p:cNvPr id="5" name="slide-subtitle">
             <a:extLst xmlns:a="http://schemas.openxmlformats.org/drawingml/2006/main">
               <a:ext uri="{FF2B5EF4-FFF2-40B4-BE49-F238E27FC236}">
-                <a16:creationId xmlns:a16="http://schemas.microsoft.com/office/drawing/2014/main" id="{DFAAC8B7-92AF-4BA8-AEAD-18AB6E423031}"/>
+                <a16:creationId xmlns:a16="http://schemas.microsoft.com/office/drawing/2014/main" id="{2B43E658-B1E0-4D68-8123-8E09BE54A66C}"/>
               </a:ext>
             </a:extLst>
           </p:cNvPr>
@@ -5235,7 +5235,7 @@
           <p:cNvPr id="6" name="bullet-1">
             <a:extLst xmlns:a="http://schemas.openxmlformats.org/drawingml/2006/main">
               <a:ext uri="{FF2B5EF4-FFF2-40B4-BE49-F238E27FC236}">
-                <a16:creationId xmlns:a16="http://schemas.microsoft.com/office/drawing/2014/main" id="{C2619019-DD93-48C8-8370-5DE4E84625DA}"/>
+                <a16:creationId xmlns:a16="http://schemas.microsoft.com/office/drawing/2014/main" id="{DF307BCA-AB88-4296-9196-FA3283D93F5B}"/>
               </a:ext>
             </a:extLst>
           </p:cNvPr>
@@ -5266,7 +5266,7 @@
           <p:cNvPr id="7" name="bullet-number-1">
             <a:extLst xmlns:a="http://schemas.openxmlformats.org/drawingml/2006/main">
               <a:ext uri="{FF2B5EF4-FFF2-40B4-BE49-F238E27FC236}">
-                <a16:creationId xmlns:a16="http://schemas.microsoft.com/office/drawing/2014/main" id="{5DCD0C94-DFD2-463A-9EB5-96FEDE2A97E5}"/>
+                <a16:creationId xmlns:a16="http://schemas.microsoft.com/office/drawing/2014/main" id="{020780AD-4EF5-4B8A-B025-179A8896E8C1}"/>
               </a:ext>
             </a:extLst>
           </p:cNvPr>
@@ -5316,7 +5316,7 @@
           <p:cNvPr id="8" name="bullet-copy-1">
             <a:extLst xmlns:a="http://schemas.openxmlformats.org/drawingml/2006/main">
               <a:ext uri="{FF2B5EF4-FFF2-40B4-BE49-F238E27FC236}">
-                <a16:creationId xmlns:a16="http://schemas.microsoft.com/office/drawing/2014/main" id="{7BE88E36-365D-4AEE-BAC2-4557C89C03F9}"/>
+                <a16:creationId xmlns:a16="http://schemas.microsoft.com/office/drawing/2014/main" id="{A7727B0F-8725-4A7B-BB6B-B454F7EF3B5A}"/>
               </a:ext>
             </a:extLst>
           </p:cNvPr>
@@ -5366,7 +5366,7 @@
           <p:cNvPr id="9" name="bullet-2">
             <a:extLst xmlns:a="http://schemas.openxmlformats.org/drawingml/2006/main">
               <a:ext uri="{FF2B5EF4-FFF2-40B4-BE49-F238E27FC236}">
-                <a16:creationId xmlns:a16="http://schemas.microsoft.com/office/drawing/2014/main" id="{23DF888F-2697-4893-A2ED-A46504B276E1}"/>
+                <a16:creationId xmlns:a16="http://schemas.microsoft.com/office/drawing/2014/main" id="{CA31709D-656D-4E93-846E-4D0D208A5EEE}"/>
               </a:ext>
             </a:extLst>
           </p:cNvPr>
@@ -5397,7 +5397,7 @@
           <p:cNvPr id="10" name="bullet-number-2">
             <a:extLst xmlns:a="http://schemas.openxmlformats.org/drawingml/2006/main">
               <a:ext uri="{FF2B5EF4-FFF2-40B4-BE49-F238E27FC236}">
-                <a16:creationId xmlns:a16="http://schemas.microsoft.com/office/drawing/2014/main" id="{05BD28EE-0E9D-4A51-9670-1B6D9C7C54D0}"/>
+                <a16:creationId xmlns:a16="http://schemas.microsoft.com/office/drawing/2014/main" id="{036558A2-32E5-411B-81D7-AECEE0673270}"/>
               </a:ext>
             </a:extLst>
           </p:cNvPr>
@@ -5447,7 +5447,7 @@
           <p:cNvPr id="11" name="bullet-copy-2">
             <a:extLst xmlns:a="http://schemas.openxmlformats.org/drawingml/2006/main">
               <a:ext uri="{FF2B5EF4-FFF2-40B4-BE49-F238E27FC236}">
-                <a16:creationId xmlns:a16="http://schemas.microsoft.com/office/drawing/2014/main" id="{AFD52292-1D5B-4AF6-AE1A-68B12BFB75E7}"/>
+                <a16:creationId xmlns:a16="http://schemas.microsoft.com/office/drawing/2014/main" id="{F6210ADA-4042-43F7-8509-8DD6DE1976D8}"/>
               </a:ext>
             </a:extLst>
           </p:cNvPr>
@@ -5487,7 +5487,7 @@
                   <a:srgbClr val="16343A"/>
                 </a:solidFill>
               </a:rPr>
-              <a:t>Useful criteria are specific and testable: “the closure keeps the flap shut during a carry test” is stronger than “it works”.</a:t>
+              <a:t>Strong criteria name a feature, an expected performance and a way to observe it.</a:t>
             </a:r>
           </a:p>
         </p:txBody>
@@ -5497,7 +5497,7 @@
           <p:cNvPr id="12" name="bullet-3">
             <a:extLst xmlns:a="http://schemas.openxmlformats.org/drawingml/2006/main">
               <a:ext uri="{FF2B5EF4-FFF2-40B4-BE49-F238E27FC236}">
-                <a16:creationId xmlns:a16="http://schemas.microsoft.com/office/drawing/2014/main" id="{F53550D7-3213-4A2B-A2ED-984C461DD0E6}"/>
+                <a16:creationId xmlns:a16="http://schemas.microsoft.com/office/drawing/2014/main" id="{7EDC2B22-A631-4541-9D0C-08C1432B8F49}"/>
               </a:ext>
             </a:extLst>
           </p:cNvPr>
@@ -5528,7 +5528,7 @@
           <p:cNvPr id="13" name="bullet-number-3">
             <a:extLst xmlns:a="http://schemas.openxmlformats.org/drawingml/2006/main">
               <a:ext uri="{FF2B5EF4-FFF2-40B4-BE49-F238E27FC236}">
-                <a16:creationId xmlns:a16="http://schemas.microsoft.com/office/drawing/2014/main" id="{E1620831-62B6-4369-BB00-C662F06AA47A}"/>
+                <a16:creationId xmlns:a16="http://schemas.microsoft.com/office/drawing/2014/main" id="{614D98CC-9A97-45B0-91BA-2CFD876F394E}"/>
               </a:ext>
             </a:extLst>
           </p:cNvPr>
@@ -5578,7 +5578,7 @@
           <p:cNvPr id="14" name="bullet-copy-3">
             <a:extLst xmlns:a="http://schemas.openxmlformats.org/drawingml/2006/main">
               <a:ext uri="{FF2B5EF4-FFF2-40B4-BE49-F238E27FC236}">
-                <a16:creationId xmlns:a16="http://schemas.microsoft.com/office/drawing/2014/main" id="{F472DDDF-09B9-4AFA-8723-3D7F80B6E3CB}"/>
+                <a16:creationId xmlns:a16="http://schemas.microsoft.com/office/drawing/2014/main" id="{89680739-0BAB-4AB3-993C-9CBF98E7F8F1}"/>
               </a:ext>
             </a:extLst>
           </p:cNvPr>
@@ -5618,7 +5618,7 @@
                   <a:srgbClr val="16343A"/>
                 </a:solidFill>
               </a:rPr>
-              <a:t>Constraints are real limits such as available materials, tools, time, cost, skill and teacher-approved construction processes.</a:t>
+              <a:t>Constraints should describe actual boundaries, not excuses.</a:t>
             </a:r>
           </a:p>
         </p:txBody>
@@ -5626,7 +5626,7 @@
     </p:spTree>
     <p:extLst>
       <p:ext uri="{BB962C8B-B14F-4D97-AF65-F5344CB8AC3E}">
-        <p14:creationId xmlns:p14="http://schemas.microsoft.com/office/powerpoint/2010/main" val="638936492"/>
+        <p14:creationId xmlns:p14="http://schemas.microsoft.com/office/powerpoint/2010/main" val="2002027317"/>
       </p:ext>
     </p:extLst>
   </p:cSld>
@@ -5657,7 +5657,7 @@
           <p:cNvPr id="6" name="closing-rule">
             <a:extLst xmlns:a="http://schemas.openxmlformats.org/drawingml/2006/main">
               <a:ext uri="{FF2B5EF4-FFF2-40B4-BE49-F238E27FC236}">
-                <a16:creationId xmlns:a16="http://schemas.microsoft.com/office/drawing/2014/main" id="{4286CA69-E950-4237-A11A-96F740D1770A}"/>
+                <a16:creationId xmlns:a16="http://schemas.microsoft.com/office/drawing/2014/main" id="{B4CA30FC-171F-40BB-B01F-16EB2D67E66B}"/>
               </a:ext>
             </a:extLst>
           </p:cNvPr>
@@ -5688,7 +5688,7 @@
           <p:cNvPr id="2" name="closing-kicker">
             <a:extLst xmlns:a="http://schemas.openxmlformats.org/drawingml/2006/main">
               <a:ext uri="{FF2B5EF4-FFF2-40B4-BE49-F238E27FC236}">
-                <a16:creationId xmlns:a16="http://schemas.microsoft.com/office/drawing/2014/main" id="{902482F4-5DD3-485C-A43C-705BA9D8EA5C}"/>
+                <a16:creationId xmlns:a16="http://schemas.microsoft.com/office/drawing/2014/main" id="{12E6BE27-0F9B-4642-B263-C0EC4FC005A7}"/>
               </a:ext>
             </a:extLst>
           </p:cNvPr>
@@ -5738,7 +5738,7 @@
           <p:cNvPr id="3" name="closing-title">
             <a:extLst xmlns:a="http://schemas.openxmlformats.org/drawingml/2006/main">
               <a:ext uri="{FF2B5EF4-FFF2-40B4-BE49-F238E27FC236}">
-                <a16:creationId xmlns:a16="http://schemas.microsoft.com/office/drawing/2014/main" id="{FA619B90-210D-45EC-9245-17357AF91D0E}"/>
+                <a16:creationId xmlns:a16="http://schemas.microsoft.com/office/drawing/2014/main" id="{08A87D19-4F63-4FBB-B6D5-A15671B6331D}"/>
               </a:ext>
             </a:extLst>
           </p:cNvPr>
@@ -5788,7 +5788,7 @@
           <p:cNvPr id="4" name="closing-copy">
             <a:extLst xmlns:a="http://schemas.openxmlformats.org/drawingml/2006/main">
               <a:ext uri="{FF2B5EF4-FFF2-40B4-BE49-F238E27FC236}">
-                <a16:creationId xmlns:a16="http://schemas.microsoft.com/office/drawing/2014/main" id="{46424A73-BF5A-4155-8843-1573FA6BB41E}"/>
+                <a16:creationId xmlns:a16="http://schemas.microsoft.com/office/drawing/2014/main" id="{D03B75C9-709B-43A9-83F7-AFB5C55B8C4B}"/>
               </a:ext>
             </a:extLst>
           </p:cNvPr>
@@ -5862,7 +5862,7 @@
                   <a:srgbClr val="E6F2EF"/>
                 </a:solidFill>
               </a:rPr>
-              <a:t>3. Continue Project Activity 1 and keep authentic evidence.</a:t>
+              <a:t>3. Continue the Design brief evidence lab and keep authentic evidence.</a:t>
             </a:r>
           </a:p>
         </p:txBody>
@@ -5872,7 +5872,7 @@
           <p:cNvPr id="5" name="closing-boundary">
             <a:extLst xmlns:a="http://schemas.openxmlformats.org/drawingml/2006/main">
               <a:ext uri="{FF2B5EF4-FFF2-40B4-BE49-F238E27FC236}">
-                <a16:creationId xmlns:a16="http://schemas.microsoft.com/office/drawing/2014/main" id="{B745A72C-5D9C-42F7-AE9E-577540A4A310}"/>
+                <a16:creationId xmlns:a16="http://schemas.microsoft.com/office/drawing/2014/main" id="{70F6BEF2-4EA9-4023-BE35-B9F6D1CEA24A}"/>
               </a:ext>
             </a:extLst>
           </p:cNvPr>
@@ -5920,7 +5920,7 @@
     </p:spTree>
     <p:extLst>
       <p:ext uri="{BB962C8B-B14F-4D97-AF65-F5344CB8AC3E}">
-        <p14:creationId xmlns:p14="http://schemas.microsoft.com/office/powerpoint/2010/main" val="1868164599"/>
+        <p14:creationId xmlns:p14="http://schemas.microsoft.com/office/powerpoint/2010/main" val="1632121055"/>
       </p:ext>
     </p:extLst>
   </p:cSld>

</xml_diff>